<commit_message>
Arizona Center for Hand to Shoulder Surgery: logo, team, titles and retirement wording in the proposal
Deck: practice logo (navy version) on the cover and closing slide; Mark
Williamson shown as CFO and his retirement referenced in the intro note;
engagement team now Steven Nikolov, Lisa Danforth CPA (CFO), Jessica
Bumphus (Controller), then Josephine Mack and staff; Who we are notes the
Intuit Elite Level Partner (QuickBooks Online) status; Josephine's title
uses an ampersand throughout.

Letter: Attn and signature Title lines set to CFO.

proposal-deck skill: builder supports a five-row team table and client
logo files; logo stored under logos/.

Co-Authored-By: Claude Fable 5.1 <noreply@anthropic.com>
Claude-Session: https://claude.ai/code/session_01KQiKzmv3wJWX8AFkC8re3n
</commit_message>
<xml_diff>
--- a/Onyx_AZHandCenter_Proposal.pptx
+++ b/Onyx_AZHandCenter_Proposal.pptx
@@ -2326,53 +2326,30 @@
           </a:p>
         </p:txBody>
       </p:sp>
-      <p:sp>
-        <p:nvSpPr>
-          <p:cNvPr id="12" name="Client wordmark"/>
-          <p:cNvSpPr txBox="1"/>
-          <p:nvPr/>
-        </p:nvSpPr>
-        <p:spPr>
-          <a:xfrm>
-            <a:off x="5212080" y="1280160"/>
-            <a:ext cx="4480560" cy="950976"/>
-          </a:xfrm>
-          <a:prstGeom prst="rect">
-            <a:avLst/>
-          </a:prstGeom>
-          <a:noFill/>
-        </p:spPr>
-        <p:txBody>
-          <a:bodyPr wrap="square" lIns="0" rIns="0" tIns="0" bIns="0" anchor="ctr">
-            <a:spAutoFit/>
-          </a:bodyPr>
-          <a:lstStyle/>
-          <a:p>
-            <a:pPr algn="l"/>
-            <a:r>
-              <a:rPr sz="1400" b="1" spc="150">
-                <a:solidFill>
-                  <a:srgbClr val="1B2A49"/>
-                </a:solidFill>
-                <a:latin typeface="Cambria"/>
-              </a:rPr>
-              <a:t>ARIZONA CENTER FOR</a:t>
-            </a:r>
-          </a:p>
-          <a:p>
-            <a:pPr algn="l"/>
-            <a:r>
-              <a:rPr sz="1400" b="1" spc="150">
-                <a:solidFill>
-                  <a:srgbClr val="1B2A49"/>
-                </a:solidFill>
-                <a:latin typeface="Cambria"/>
-              </a:rPr>
-              <a:t>HAND TO SHOULDER SURGERY</a:t>
-            </a:r>
-          </a:p>
-        </p:txBody>
-      </p:sp>
+      <p:pic>
+        <p:nvPicPr>
+          <p:cNvPr id="12" name="Client logo" descr="AZHandCenter_navy.png"/>
+          <p:cNvPicPr>
+            <a:picLocks noChangeAspect="1"/>
+          </p:cNvPicPr>
+          <p:nvPr/>
+        </p:nvPicPr>
+        <p:blipFill>
+          <a:blip r:embed="rId5"/>
+          <a:stretch>
+            <a:fillRect/>
+          </a:stretch>
+        </p:blipFill>
+        <p:spPr>
+          <a:xfrm>
+            <a:off x="5212080" y="1508760"/>
+            <a:ext cx="4480560" cy="711524"/>
+          </a:xfrm>
+          <a:prstGeom prst="rect">
+            <a:avLst/>
+          </a:prstGeom>
+        </p:spPr>
+      </p:pic>
       <p:sp>
         <p:nvSpPr>
           <p:cNvPr id="7" name="Text 3"/>
@@ -2456,7 +2433,7 @@
                   <a:schemeClr val="accent3"/>
                 </a:solidFill>
               </a:rPr>
-              <a:t>Attn: Mark Williamson, [Title]</a:t>
+              <a:t>Attn: Mark Williamson, CFO</a:t>
             </a:r>
             <a:endParaRPr lang="en-US" sz="1200" dirty="0"/>
           </a:p>
@@ -2570,7 +2547,7 @@
                   <a:schemeClr val="tx1"/>
                 </a:solidFill>
               </a:rPr>
-              <a:t>Josephine Mack, Chief of Staff and Client Relations</a:t>
+              <a:t>Josephine Mack, Chief of Staff &amp; Client Relations</a:t>
             </a:r>
             <a:endParaRPr lang="en-US" sz="1200" dirty="0"/>
           </a:p>
@@ -8847,7 +8824,7 @@
                   <a:schemeClr val="accent3"/>
                 </a:solidFill>
               </a:rPr>
-              <a:t>Josephine Mack, Chief of Staff and Client Relations  |  jmack@onyxcfo.com</a:t>
+              <a:t>Josephine Mack, Chief of Staff &amp; Client Relations  |  jmack@onyxcfo.com</a:t>
             </a:r>
             <a:endParaRPr lang="en-US" sz="1100" dirty="0"/>
           </a:p>
@@ -9120,65 +9097,30 @@
           </a:p>
         </p:txBody>
       </p:sp>
-      <p:sp>
-        <p:nvSpPr>
-          <p:cNvPr id="8" name="Client wordmark"/>
-          <p:cNvSpPr txBox="1"/>
-          <p:nvPr/>
-        </p:nvSpPr>
-        <p:spPr>
-          <a:xfrm>
-            <a:off x="8458200" y="2258568"/>
-            <a:ext cx="2834640" cy="893369"/>
-          </a:xfrm>
-          <a:prstGeom prst="rect">
-            <a:avLst/>
-          </a:prstGeom>
-          <a:noFill/>
-        </p:spPr>
-        <p:txBody>
-          <a:bodyPr wrap="square" lIns="0" rIns="0" tIns="0" bIns="0" anchor="ctr">
-            <a:spAutoFit/>
-          </a:bodyPr>
-          <a:lstStyle/>
-          <a:p>
-            <a:pPr algn="ctr"/>
-            <a:r>
-              <a:rPr sz="1200" b="1" spc="150">
-                <a:solidFill>
-                  <a:srgbClr val="1B2A49"/>
-                </a:solidFill>
-                <a:latin typeface="Cambria"/>
-              </a:rPr>
-              <a:t>ARIZONA CENTER</a:t>
-            </a:r>
-          </a:p>
-          <a:p>
-            <a:pPr algn="ctr"/>
-            <a:r>
-              <a:rPr sz="1200" b="1" spc="150">
-                <a:solidFill>
-                  <a:srgbClr val="1B2A49"/>
-                </a:solidFill>
-                <a:latin typeface="Cambria"/>
-              </a:rPr>
-              <a:t>FOR HAND TO</a:t>
-            </a:r>
-          </a:p>
-          <a:p>
-            <a:pPr algn="ctr"/>
-            <a:r>
-              <a:rPr sz="1200" b="1" spc="150">
-                <a:solidFill>
-                  <a:srgbClr val="1B2A49"/>
-                </a:solidFill>
-                <a:latin typeface="Cambria"/>
-              </a:rPr>
-              <a:t>SHOULDER SURGERY</a:t>
-            </a:r>
-          </a:p>
-        </p:txBody>
-      </p:sp>
+      <p:pic>
+        <p:nvPicPr>
+          <p:cNvPr id="8" name="Client logo" descr="AZHandCenter_navy.png"/>
+          <p:cNvPicPr>
+            <a:picLocks noChangeAspect="1"/>
+          </p:cNvPicPr>
+          <p:nvPr/>
+        </p:nvPicPr>
+        <p:blipFill>
+          <a:blip r:embed="rId4"/>
+          <a:stretch>
+            <a:fillRect/>
+          </a:stretch>
+        </p:blipFill>
+        <p:spPr>
+          <a:xfrm>
+            <a:off x="8458200" y="2480178"/>
+            <a:ext cx="2834640" cy="450148"/>
+          </a:xfrm>
+          <a:prstGeom prst="rect">
+            <a:avLst/>
+          </a:prstGeom>
+        </p:spPr>
+      </p:pic>
       <p:sp>
         <p:nvSpPr>
           <p:cNvPr id="7" name="Text 4"/>
@@ -9237,7 +9179,7 @@
                   <a:schemeClr val="bg1"/>
                 </a:solidFill>
               </a:rPr>
-              <a:t>Mark Williamson, [Title]</a:t>
+              <a:t>Mark Williamson, CFO</a:t>
             </a:r>
             <a:endParaRPr lang="en-US" sz="1100" dirty="0"/>
           </a:p>
@@ -9407,7 +9349,7 @@
                   <a:schemeClr val="accent3"/>
                 </a:solidFill>
               </a:rPr>
-              <a:t>Mark Williamson, [Title]</a:t>
+              <a:t>Mark Williamson, CFO</a:t>
             </a:r>
             <a:endParaRPr lang="en-US" sz="1200" dirty="0"/>
           </a:p>
@@ -9520,7 +9462,7 @@
                   <a:schemeClr val="tx1"/>
                 </a:solidFill>
               </a:rPr>
-              <a:t>Thank you for the time you gave us on our October 5 call. This proposal accompanies the enclosed engagement letter and describes how Onyx Accounting Group would support Arizona Center for Hand to Shoulder Surgery as you reduce your hours.</a:t>
+              <a:t>Thank you for the time you gave us on our October 5 call. This proposal accompanies the enclosed engagement letter and describes how Onyx Accounting Group would support Arizona Center for Hand to Shoulder Surgery as you move toward retirement.</a:t>
             </a:r>
             <a:endParaRPr lang="en-US" sz="1250" dirty="0"/>
           </a:p>
@@ -9540,7 +9482,7 @@
                   <a:schemeClr val="tx1"/>
                 </a:solidFill>
               </a:rPr>
-              <a:t>We have organized it around what we heard. The first priority is continuity: a consistent senior finance contact for the physicians, knowledge transfer from you, and a monthly close that stays on track across all three entities. Behind that sits the work that needs controller and CFO judgment: physician compensation and the mid-month bonus, revenue-cycle and borrowing-base reporting, less manual work between eClinicalWorks, payroll and QuickBooks Online, and an automation roadmap with review controls.</a:t>
+              <a:t>We have organized it around what we heard. The first priority is continuity: a consistent senior finance contact for the physicians, knowledge transfer from you before you retire, and a monthly close that stays on track across all three entities. Behind that sits the work that needs controller and CFO judgment: physician compensation and the mid-month bonus, revenue-cycle and borrowing-base reporting, less manual work between eClinicalWorks, payroll and QuickBooks Online, and an automation roadmap with review controls.</a:t>
             </a:r>
             <a:endParaRPr lang="en-US" sz="1250" dirty="0"/>
           </a:p>
@@ -10845,7 +10787,7 @@
                   <a:schemeClr val="tx1"/>
                 </a:solidFill>
               </a:rPr>
-              <a:t>Onyx Accounting Group is a Scottsdale, Arizona accounting firm that provides bookkeeping, controller and CFO services to privately held companies. We work inside our clients' own systems, including QuickBooks Online, as an extension of their finance team, and we are built to cover the full range from transaction detail to the owner's table.</a:t>
+              <a:t>Onyx Accounting Group is a Scottsdale, Arizona accounting firm that provides bookkeeping, controller and CFO services to privately held companies. We are an Elite Level Partner of Intuit (QuickBooks Online) and work inside our clients' own systems as an extension of their finance team, covering the full range from transaction detail to the owner's table.</a:t>
             </a:r>
             <a:endParaRPr lang="en-US" sz="1250" dirty="0"/>
           </a:p>
@@ -11819,7 +11761,7 @@
                   <a:schemeClr val="accent3"/>
                 </a:solidFill>
               </a:rPr>
-              <a:t>The principal leads the engagement and stays on it as your relationship lead. An ONYX controller, named at kickoff, leads the controller work. Staff support is assigned as the work settles, and the mix is adjusted with you.</a:t>
+              <a:t>The principal leads the engagement and stays on it as your relationship lead. Lisa Danforth, CPA, provides CFO-level support, and Jessica Bumphus leads the controller work. Staff support is assigned as the work settles, and the mix is adjusted with you.</a:t>
             </a:r>
             <a:endParaRPr lang="en-US" sz="1250" dirty="0"/>
           </a:p>
@@ -11840,8 +11782,8 @@
           </p:nvPr>
         </p:nvGraphicFramePr>
         <p:xfrm>
-          <a:off x="548640" y="2148840"/>
-          <a:ext cx="11091672" cy="3474720"/>
+          <a:off x="548640" y="2057400"/>
+          <a:ext cx="11091672" cy="3108960"/>
         </p:xfrm>
         <a:graphic>
           <a:graphicData uri="http://schemas.openxmlformats.org/drawingml/2006/table">
@@ -11887,7 +11829,7 @@
                         <a:buNone/>
                       </a:pPr>
                       <a:r>
-                        <a:rPr lang="en-US" sz="1100" b="1" dirty="0">
+                        <a:rPr lang="en-US" sz="1050" b="1" dirty="0">
                           <a:solidFill>
                             <a:srgbClr val="FFFFFF"/>
                           </a:solidFill>
@@ -11955,7 +11897,7 @@
                         <a:buNone/>
                       </a:pPr>
                       <a:r>
-                        <a:rPr lang="en-US" sz="1100" b="1" dirty="0">
+                        <a:rPr lang="en-US" sz="1050" b="1" dirty="0">
                           <a:solidFill>
                             <a:srgbClr val="FFFFFF"/>
                           </a:solidFill>
@@ -12023,7 +11965,7 @@
                         <a:buNone/>
                       </a:pPr>
                       <a:r>
-                        <a:rPr lang="en-US" sz="1100" b="1" dirty="0">
+                        <a:rPr lang="en-US" sz="1050" b="1" dirty="0">
                           <a:solidFill>
                             <a:srgbClr val="FFFFFF"/>
                           </a:solidFill>
@@ -12091,7 +12033,7 @@
                         <a:buNone/>
                       </a:pPr>
                       <a:r>
-                        <a:rPr lang="en-US" sz="1100" b="1" dirty="0">
+                        <a:rPr lang="en-US" sz="1050" b="1" dirty="0">
                           <a:solidFill>
                             <a:srgbClr val="FFFFFF"/>
                           </a:solidFill>
@@ -12156,7 +12098,7 @@
                   </a:ext>
                 </a:extLst>
               </a:tr>
-              <a:tr h="868680">
+              <a:tr h="548640">
                 <a:tc>
                   <a:txBody>
                     <a:bodyPr/>
@@ -12166,7 +12108,7 @@
                         <a:buNone/>
                       </a:pPr>
                       <a:r>
-                        <a:rPr lang="en-US" sz="1100" b="1" dirty="0">
+                        <a:rPr lang="en-US" sz="1050" b="1" dirty="0">
                           <a:solidFill>
                             <a:srgbClr val="16181D"/>
                           </a:solidFill>
@@ -12187,7 +12129,7 @@
                         <a:buNone/>
                       </a:pPr>
                       <a:r>
-                        <a:rPr lang="en-US" sz="1100" b="1" dirty="0">
+                        <a:rPr lang="en-US" sz="1050" b="1" dirty="0">
                           <a:solidFill>
                             <a:srgbClr val="16181D"/>
                           </a:solidFill>
@@ -12252,7 +12194,7 @@
                         <a:buNone/>
                       </a:pPr>
                       <a:r>
-                        <a:rPr lang="en-US" sz="1100" dirty="0">
+                        <a:rPr lang="en-US" sz="1050" dirty="0">
                           <a:solidFill>
                             <a:srgbClr val="16181D"/>
                           </a:solidFill>
@@ -12317,7 +12259,7 @@
                         <a:buNone/>
                       </a:pPr>
                       <a:r>
-                        <a:rPr lang="en-US" sz="1100" dirty="0">
+                        <a:rPr lang="en-US" sz="1050" dirty="0">
                           <a:solidFill>
                             <a:srgbClr val="16181D"/>
                           </a:solidFill>
@@ -12325,7 +12267,7 @@
                           <a:ea typeface="Calibri" pitchFamily="34" charset="-122"/>
                           <a:cs typeface="Calibri" pitchFamily="34" charset="-120"/>
                         </a:rPr>
-                        <a:t>Overall direction and quality. CFO-level work: close design, board and lender reporting, budgeting and forecasting, borrowing-base and covenant matters, direction to the finance team.</a:t>
+                        <a:t>Overall direction and quality. CFO-level work: close design, board and lender reporting, budgeting and forecasting, covenant matters, direction to the finance team.</a:t>
                       </a:r>
                       <a:endParaRPr lang="en-US" sz="1100" dirty="0">
                         <a:latin typeface="Calibri" charset="0"/>
@@ -12382,7 +12324,7 @@
                         <a:buNone/>
                       </a:pPr>
                       <a:r>
-                        <a:rPr lang="en-US" sz="1100" dirty="0">
+                        <a:rPr lang="en-US" sz="1050" dirty="0">
                           <a:solidFill>
                             <a:srgbClr val="16181D"/>
                           </a:solidFill>
@@ -12444,7 +12386,7 @@
                   </a:ext>
                 </a:extLst>
               </a:tr>
-              <a:tr h="685800">
+              <a:tr h="548640">
                 <a:tc>
                   <a:txBody>
                     <a:bodyPr/>
@@ -12454,7 +12396,583 @@
                         <a:buNone/>
                       </a:pPr>
                       <a:r>
-                        <a:rPr lang="en-US" sz="1100" b="1" dirty="0">
+                        <a:rPr lang="en-US" sz="1050" b="1" dirty="0">
+                          <a:solidFill>
+                            <a:srgbClr val="16181D"/>
+                          </a:solidFill>
+                          <a:latin typeface="Calibri" pitchFamily="34" charset="0"/>
+                          <a:ea typeface="Calibri" pitchFamily="34" charset="-122"/>
+                          <a:cs typeface="Calibri" pitchFamily="34" charset="-120"/>
+                        </a:rPr>
+                        <a:t>Lisa Danforth, CPA</a:t>
+                      </a:r>
+                      <a:endParaRPr lang="en-US" sz="1100" dirty="0">
+                        <a:latin typeface="Calibri" charset="0"/>
+                        <a:ea typeface="Calibri" charset="0"/>
+                        <a:cs typeface="Calibri" charset="0"/>
+                      </a:endParaRPr>
+                    </a:p>
+                    <a:p>
+                      <a:pPr marL="0" indent="0">
+                        <a:buNone/>
+                      </a:pPr>
+                      <a:r>
+                        <a:rPr lang="en-US" sz="1050" b="1" dirty="0">
+                          <a:solidFill>
+                            <a:srgbClr val="16181D"/>
+                          </a:solidFill>
+                          <a:latin typeface="Calibri" pitchFamily="34" charset="0"/>
+                          <a:ea typeface="Calibri" pitchFamily="34" charset="-122"/>
+                          <a:cs typeface="Calibri" pitchFamily="34" charset="-120"/>
+                        </a:rPr>
+                        <a:t>CFO</a:t>
+                      </a:r>
+                      <a:endParaRPr lang="en-US" sz="1100" dirty="0">
+                        <a:latin typeface="Calibri" charset="0"/>
+                        <a:ea typeface="Calibri" charset="0"/>
+                        <a:cs typeface="Calibri" charset="0"/>
+                      </a:endParaRPr>
+                    </a:p>
+                  </a:txBody>
+                  <a:tcPr marL="88900" marR="88900" marT="63500" marB="63500">
+                    <a:lnL w="9525" cap="flat" cmpd="sng" algn="ctr">
+                      <a:solidFill>
+                        <a:srgbClr val="D5D9E0"/>
+                      </a:solidFill>
+                      <a:prstDash val="solid"/>
+                      <a:round/>
+                      <a:headEnd type="none" w="med" len="med"/>
+                      <a:tailEnd type="none" w="med" len="med"/>
+                    </a:lnL>
+                    <a:lnR w="9525" cap="flat" cmpd="sng" algn="ctr">
+                      <a:solidFill>
+                        <a:srgbClr val="D5D9E0"/>
+                      </a:solidFill>
+                      <a:prstDash val="solid"/>
+                      <a:round/>
+                      <a:headEnd type="none" w="med" len="med"/>
+                      <a:tailEnd type="none" w="med" len="med"/>
+                    </a:lnR>
+                    <a:lnT w="9525" cap="flat" cmpd="sng" algn="ctr">
+                      <a:solidFill>
+                        <a:srgbClr val="D5D9E0"/>
+                      </a:solidFill>
+                      <a:prstDash val="solid"/>
+                      <a:round/>
+                      <a:headEnd type="none" w="med" len="med"/>
+                      <a:tailEnd type="none" w="med" len="med"/>
+                    </a:lnT>
+                    <a:lnB w="9525" cap="flat" cmpd="sng" algn="ctr">
+                      <a:solidFill>
+                        <a:srgbClr val="D5D9E0"/>
+                      </a:solidFill>
+                      <a:prstDash val="solid"/>
+                      <a:round/>
+                      <a:headEnd type="none" w="med" len="med"/>
+                      <a:tailEnd type="none" w="med" len="med"/>
+                    </a:lnB>
+                  </a:tcPr>
+                </a:tc>
+                <a:tc>
+                  <a:txBody>
+                    <a:bodyPr/>
+                    <a:lstStyle/>
+                    <a:p>
+                      <a:pPr marL="0" indent="0">
+                        <a:buNone/>
+                      </a:pPr>
+                      <a:r>
+                        <a:rPr lang="en-US" sz="1050" dirty="0">
+                          <a:solidFill>
+                            <a:srgbClr val="16181D"/>
+                          </a:solidFill>
+                          <a:latin typeface="Calibri" pitchFamily="34" charset="0"/>
+                          <a:ea typeface="Calibri" pitchFamily="34" charset="-122"/>
+                          <a:cs typeface="Calibri" pitchFamily="34" charset="-120"/>
+                        </a:rPr>
+                        <a:t>CFO support</a:t>
+                      </a:r>
+                      <a:endParaRPr lang="en-US" sz="1100" dirty="0">
+                        <a:latin typeface="Calibri" charset="0"/>
+                        <a:ea typeface="Calibri" charset="0"/>
+                        <a:cs typeface="Calibri" charset="0"/>
+                      </a:endParaRPr>
+                    </a:p>
+                  </a:txBody>
+                  <a:tcPr marL="88900" marR="88900" marT="63500" marB="63500">
+                    <a:lnL w="9525" cap="flat" cmpd="sng" algn="ctr">
+                      <a:solidFill>
+                        <a:srgbClr val="D5D9E0"/>
+                      </a:solidFill>
+                      <a:prstDash val="solid"/>
+                      <a:round/>
+                      <a:headEnd type="none" w="med" len="med"/>
+                      <a:tailEnd type="none" w="med" len="med"/>
+                    </a:lnL>
+                    <a:lnR w="9525" cap="flat" cmpd="sng" algn="ctr">
+                      <a:solidFill>
+                        <a:srgbClr val="D5D9E0"/>
+                      </a:solidFill>
+                      <a:prstDash val="solid"/>
+                      <a:round/>
+                      <a:headEnd type="none" w="med" len="med"/>
+                      <a:tailEnd type="none" w="med" len="med"/>
+                    </a:lnR>
+                    <a:lnT w="9525" cap="flat" cmpd="sng" algn="ctr">
+                      <a:solidFill>
+                        <a:srgbClr val="D5D9E0"/>
+                      </a:solidFill>
+                      <a:prstDash val="solid"/>
+                      <a:round/>
+                      <a:headEnd type="none" w="med" len="med"/>
+                      <a:tailEnd type="none" w="med" len="med"/>
+                    </a:lnT>
+                    <a:lnB w="9525" cap="flat" cmpd="sng" algn="ctr">
+                      <a:solidFill>
+                        <a:srgbClr val="D5D9E0"/>
+                      </a:solidFill>
+                      <a:prstDash val="solid"/>
+                      <a:round/>
+                      <a:headEnd type="none" w="med" len="med"/>
+                      <a:tailEnd type="none" w="med" len="med"/>
+                    </a:lnB>
+                  </a:tcPr>
+                </a:tc>
+                <a:tc>
+                  <a:txBody>
+                    <a:bodyPr/>
+                    <a:lstStyle/>
+                    <a:p>
+                      <a:pPr marL="0" indent="0">
+                        <a:buNone/>
+                      </a:pPr>
+                      <a:r>
+                        <a:rPr lang="en-US" sz="1050" dirty="0">
+                          <a:solidFill>
+                            <a:srgbClr val="16181D"/>
+                          </a:solidFill>
+                          <a:latin typeface="Calibri" pitchFamily="34" charset="0"/>
+                          <a:ea typeface="Calibri" pitchFamily="34" charset="-122"/>
+                          <a:cs typeface="Calibri" pitchFamily="34" charset="-120"/>
+                        </a:rPr>
+                        <a:t>CFO-level support alongside Steven: management and board reporting, physician compensation review, budgeting and forecasting, a second senior contact for the physicians.</a:t>
+                      </a:r>
+                      <a:endParaRPr lang="en-US" sz="1100" dirty="0">
+                        <a:latin typeface="Calibri" charset="0"/>
+                        <a:ea typeface="Calibri" charset="0"/>
+                        <a:cs typeface="Calibri" charset="0"/>
+                      </a:endParaRPr>
+                    </a:p>
+                  </a:txBody>
+                  <a:tcPr marL="88900" marR="88900" marT="63500" marB="63500">
+                    <a:lnL w="9525" cap="flat" cmpd="sng" algn="ctr">
+                      <a:solidFill>
+                        <a:srgbClr val="D5D9E0"/>
+                      </a:solidFill>
+                      <a:prstDash val="solid"/>
+                      <a:round/>
+                      <a:headEnd type="none" w="med" len="med"/>
+                      <a:tailEnd type="none" w="med" len="med"/>
+                    </a:lnL>
+                    <a:lnR w="9525" cap="flat" cmpd="sng" algn="ctr">
+                      <a:solidFill>
+                        <a:srgbClr val="D5D9E0"/>
+                      </a:solidFill>
+                      <a:prstDash val="solid"/>
+                      <a:round/>
+                      <a:headEnd type="none" w="med" len="med"/>
+                      <a:tailEnd type="none" w="med" len="med"/>
+                    </a:lnR>
+                    <a:lnT w="9525" cap="flat" cmpd="sng" algn="ctr">
+                      <a:solidFill>
+                        <a:srgbClr val="D5D9E0"/>
+                      </a:solidFill>
+                      <a:prstDash val="solid"/>
+                      <a:round/>
+                      <a:headEnd type="none" w="med" len="med"/>
+                      <a:tailEnd type="none" w="med" len="med"/>
+                    </a:lnT>
+                    <a:lnB w="9525" cap="flat" cmpd="sng" algn="ctr">
+                      <a:solidFill>
+                        <a:srgbClr val="D5D9E0"/>
+                      </a:solidFill>
+                      <a:prstDash val="solid"/>
+                      <a:round/>
+                      <a:headEnd type="none" w="med" len="med"/>
+                      <a:tailEnd type="none" w="med" len="med"/>
+                    </a:lnB>
+                  </a:tcPr>
+                </a:tc>
+                <a:tc>
+                  <a:txBody>
+                    <a:bodyPr/>
+                    <a:lstStyle/>
+                    <a:p>
+                      <a:pPr marL="0" indent="0">
+                        <a:buNone/>
+                      </a:pPr>
+                      <a:r>
+                        <a:rPr lang="en-US" sz="1050" dirty="0">
+                          <a:solidFill>
+                            <a:srgbClr val="16181D"/>
+                          </a:solidFill>
+                          <a:latin typeface="Calibri" pitchFamily="34" charset="0"/>
+                          <a:ea typeface="Calibri" pitchFamily="34" charset="-122"/>
+                          <a:cs typeface="Calibri" pitchFamily="34" charset="-120"/>
+                        </a:rPr>
+                        <a:t>Weekly during the first 90 days, then as needed.</a:t>
+                      </a:r>
+                      <a:endParaRPr lang="en-US" sz="1100" dirty="0">
+                        <a:latin typeface="Calibri" charset="0"/>
+                        <a:ea typeface="Calibri" charset="0"/>
+                        <a:cs typeface="Calibri" charset="0"/>
+                      </a:endParaRPr>
+                    </a:p>
+                  </a:txBody>
+                  <a:tcPr marL="88900" marR="88900" marT="63500" marB="63500">
+                    <a:lnL w="9525" cap="flat" cmpd="sng" algn="ctr">
+                      <a:solidFill>
+                        <a:srgbClr val="D5D9E0"/>
+                      </a:solidFill>
+                      <a:prstDash val="solid"/>
+                      <a:round/>
+                      <a:headEnd type="none" w="med" len="med"/>
+                      <a:tailEnd type="none" w="med" len="med"/>
+                    </a:lnL>
+                    <a:lnR w="9525" cap="flat" cmpd="sng" algn="ctr">
+                      <a:solidFill>
+                        <a:srgbClr val="D5D9E0"/>
+                      </a:solidFill>
+                      <a:prstDash val="solid"/>
+                      <a:round/>
+                      <a:headEnd type="none" w="med" len="med"/>
+                      <a:tailEnd type="none" w="med" len="med"/>
+                    </a:lnR>
+                    <a:lnT w="9525" cap="flat" cmpd="sng" algn="ctr">
+                      <a:solidFill>
+                        <a:srgbClr val="D5D9E0"/>
+                      </a:solidFill>
+                      <a:prstDash val="solid"/>
+                      <a:round/>
+                      <a:headEnd type="none" w="med" len="med"/>
+                      <a:tailEnd type="none" w="med" len="med"/>
+                    </a:lnT>
+                    <a:lnB w="9525" cap="flat" cmpd="sng" algn="ctr">
+                      <a:solidFill>
+                        <a:srgbClr val="D5D9E0"/>
+                      </a:solidFill>
+                      <a:prstDash val="solid"/>
+                      <a:round/>
+                      <a:headEnd type="none" w="med" len="med"/>
+                      <a:tailEnd type="none" w="med" len="med"/>
+                    </a:lnB>
+                  </a:tcPr>
+                </a:tc>
+                <a:extLst>
+                  <a:ext uri="{0D108BD9-81ED-4DB2-BD59-A6C34878D82A}">
+                    <a16:rowId xmlns:a16="http://schemas.microsoft.com/office/drawing/2014/main" val="10002"/>
+                  </a:ext>
+                </a:extLst>
+              </a:tr>
+              <a:tr h="548640">
+                <a:tc>
+                  <a:txBody>
+                    <a:bodyPr/>
+                    <a:lstStyle/>
+                    <a:p>
+                      <a:pPr marL="0" indent="0">
+                        <a:buNone/>
+                      </a:pPr>
+                      <a:r>
+                        <a:rPr lang="en-US" sz="1050" b="1" dirty="0">
+                          <a:solidFill>
+                            <a:srgbClr val="16181D"/>
+                          </a:solidFill>
+                          <a:latin typeface="Calibri" pitchFamily="34" charset="0"/>
+                          <a:ea typeface="Calibri" pitchFamily="34" charset="-122"/>
+                          <a:cs typeface="Calibri" pitchFamily="34" charset="-120"/>
+                        </a:rPr>
+                        <a:t>Jessica Bumphus</a:t>
+                      </a:r>
+                      <a:endParaRPr lang="en-US" sz="1100" dirty="0">
+                        <a:latin typeface="Calibri" charset="0"/>
+                        <a:ea typeface="Calibri" charset="0"/>
+                        <a:cs typeface="Calibri" charset="0"/>
+                      </a:endParaRPr>
+                    </a:p>
+                    <a:p>
+                      <a:pPr marL="0" indent="0">
+                        <a:buNone/>
+                      </a:pPr>
+                      <a:r>
+                        <a:rPr lang="en-US" sz="1050" b="1" dirty="0">
+                          <a:solidFill>
+                            <a:srgbClr val="16181D"/>
+                          </a:solidFill>
+                          <a:latin typeface="Calibri" pitchFamily="34" charset="0"/>
+                          <a:ea typeface="Calibri" pitchFamily="34" charset="-122"/>
+                          <a:cs typeface="Calibri" pitchFamily="34" charset="-120"/>
+                        </a:rPr>
+                        <a:t>Controller</a:t>
+                      </a:r>
+                      <a:endParaRPr lang="en-US" sz="1100" dirty="0">
+                        <a:latin typeface="Calibri" charset="0"/>
+                        <a:ea typeface="Calibri" charset="0"/>
+                        <a:cs typeface="Calibri" charset="0"/>
+                      </a:endParaRPr>
+                    </a:p>
+                  </a:txBody>
+                  <a:tcPr marL="88900" marR="88900" marT="63500" marB="63500">
+                    <a:lnL w="9525" cap="flat" cmpd="sng" algn="ctr">
+                      <a:solidFill>
+                        <a:srgbClr val="D5D9E0"/>
+                      </a:solidFill>
+                      <a:prstDash val="solid"/>
+                      <a:round/>
+                      <a:headEnd type="none" w="med" len="med"/>
+                      <a:tailEnd type="none" w="med" len="med"/>
+                    </a:lnL>
+                    <a:lnR w="9525" cap="flat" cmpd="sng" algn="ctr">
+                      <a:solidFill>
+                        <a:srgbClr val="D5D9E0"/>
+                      </a:solidFill>
+                      <a:prstDash val="solid"/>
+                      <a:round/>
+                      <a:headEnd type="none" w="med" len="med"/>
+                      <a:tailEnd type="none" w="med" len="med"/>
+                    </a:lnR>
+                    <a:lnT w="9525" cap="flat" cmpd="sng" algn="ctr">
+                      <a:solidFill>
+                        <a:srgbClr val="D5D9E0"/>
+                      </a:solidFill>
+                      <a:prstDash val="solid"/>
+                      <a:round/>
+                      <a:headEnd type="none" w="med" len="med"/>
+                      <a:tailEnd type="none" w="med" len="med"/>
+                    </a:lnT>
+                    <a:lnB w="9525" cap="flat" cmpd="sng" algn="ctr">
+                      <a:solidFill>
+                        <a:srgbClr val="D5D9E0"/>
+                      </a:solidFill>
+                      <a:prstDash val="solid"/>
+                      <a:round/>
+                      <a:headEnd type="none" w="med" len="med"/>
+                      <a:tailEnd type="none" w="med" len="med"/>
+                    </a:lnB>
+                  </a:tcPr>
+                </a:tc>
+                <a:tc>
+                  <a:txBody>
+                    <a:bodyPr/>
+                    <a:lstStyle/>
+                    <a:p>
+                      <a:pPr marL="0" indent="0">
+                        <a:buNone/>
+                      </a:pPr>
+                      <a:r>
+                        <a:rPr lang="en-US" sz="1050" dirty="0">
+                          <a:solidFill>
+                            <a:srgbClr val="16181D"/>
+                          </a:solidFill>
+                          <a:latin typeface="Calibri" pitchFamily="34" charset="0"/>
+                          <a:ea typeface="Calibri" pitchFamily="34" charset="-122"/>
+                          <a:cs typeface="Calibri" pitchFamily="34" charset="-120"/>
+                        </a:rPr>
+                        <a:t>ONYX controller</a:t>
+                      </a:r>
+                      <a:endParaRPr lang="en-US" sz="1100" dirty="0">
+                        <a:latin typeface="Calibri" charset="0"/>
+                        <a:ea typeface="Calibri" charset="0"/>
+                        <a:cs typeface="Calibri" charset="0"/>
+                      </a:endParaRPr>
+                    </a:p>
+                  </a:txBody>
+                  <a:tcPr marL="88900" marR="88900" marT="63500" marB="63500">
+                    <a:lnL w="9525" cap="flat" cmpd="sng" algn="ctr">
+                      <a:solidFill>
+                        <a:srgbClr val="D5D9E0"/>
+                      </a:solidFill>
+                      <a:prstDash val="solid"/>
+                      <a:round/>
+                      <a:headEnd type="none" w="med" len="med"/>
+                      <a:tailEnd type="none" w="med" len="med"/>
+                    </a:lnL>
+                    <a:lnR w="9525" cap="flat" cmpd="sng" algn="ctr">
+                      <a:solidFill>
+                        <a:srgbClr val="D5D9E0"/>
+                      </a:solidFill>
+                      <a:prstDash val="solid"/>
+                      <a:round/>
+                      <a:headEnd type="none" w="med" len="med"/>
+                      <a:tailEnd type="none" w="med" len="med"/>
+                    </a:lnR>
+                    <a:lnT w="9525" cap="flat" cmpd="sng" algn="ctr">
+                      <a:solidFill>
+                        <a:srgbClr val="D5D9E0"/>
+                      </a:solidFill>
+                      <a:prstDash val="solid"/>
+                      <a:round/>
+                      <a:headEnd type="none" w="med" len="med"/>
+                      <a:tailEnd type="none" w="med" len="med"/>
+                    </a:lnT>
+                    <a:lnB w="9525" cap="flat" cmpd="sng" algn="ctr">
+                      <a:solidFill>
+                        <a:srgbClr val="D5D9E0"/>
+                      </a:solidFill>
+                      <a:prstDash val="solid"/>
+                      <a:round/>
+                      <a:headEnd type="none" w="med" len="med"/>
+                      <a:tailEnd type="none" w="med" len="med"/>
+                    </a:lnB>
+                  </a:tcPr>
+                </a:tc>
+                <a:tc>
+                  <a:txBody>
+                    <a:bodyPr/>
+                    <a:lstStyle/>
+                    <a:p>
+                      <a:pPr marL="0" indent="0">
+                        <a:buNone/>
+                      </a:pPr>
+                      <a:r>
+                        <a:rPr lang="en-US" sz="1050" dirty="0">
+                          <a:solidFill>
+                            <a:srgbClr val="16181D"/>
+                          </a:solidFill>
+                          <a:latin typeface="Calibri" pitchFamily="34" charset="0"/>
+                          <a:ea typeface="Calibri" pitchFamily="34" charset="-122"/>
+                          <a:cs typeface="Calibri" pitchFamily="34" charset="-120"/>
+                        </a:rPr>
+                        <a:t>Leads the monthly close, reviews the team's reconciliations and entries, supports physician compensation and revenue-cycle reporting, drives the systems and automation work.</a:t>
+                      </a:r>
+                      <a:endParaRPr lang="en-US" sz="1100" dirty="0">
+                        <a:latin typeface="Calibri" charset="0"/>
+                        <a:ea typeface="Calibri" charset="0"/>
+                        <a:cs typeface="Calibri" charset="0"/>
+                      </a:endParaRPr>
+                    </a:p>
+                  </a:txBody>
+                  <a:tcPr marL="88900" marR="88900" marT="63500" marB="63500">
+                    <a:lnL w="9525" cap="flat" cmpd="sng" algn="ctr">
+                      <a:solidFill>
+                        <a:srgbClr val="D5D9E0"/>
+                      </a:solidFill>
+                      <a:prstDash val="solid"/>
+                      <a:round/>
+                      <a:headEnd type="none" w="med" len="med"/>
+                      <a:tailEnd type="none" w="med" len="med"/>
+                    </a:lnL>
+                    <a:lnR w="9525" cap="flat" cmpd="sng" algn="ctr">
+                      <a:solidFill>
+                        <a:srgbClr val="D5D9E0"/>
+                      </a:solidFill>
+                      <a:prstDash val="solid"/>
+                      <a:round/>
+                      <a:headEnd type="none" w="med" len="med"/>
+                      <a:tailEnd type="none" w="med" len="med"/>
+                    </a:lnR>
+                    <a:lnT w="9525" cap="flat" cmpd="sng" algn="ctr">
+                      <a:solidFill>
+                        <a:srgbClr val="D5D9E0"/>
+                      </a:solidFill>
+                      <a:prstDash val="solid"/>
+                      <a:round/>
+                      <a:headEnd type="none" w="med" len="med"/>
+                      <a:tailEnd type="none" w="med" len="med"/>
+                    </a:lnT>
+                    <a:lnB w="9525" cap="flat" cmpd="sng" algn="ctr">
+                      <a:solidFill>
+                        <a:srgbClr val="D5D9E0"/>
+                      </a:solidFill>
+                      <a:prstDash val="solid"/>
+                      <a:round/>
+                      <a:headEnd type="none" w="med" len="med"/>
+                      <a:tailEnd type="none" w="med" len="med"/>
+                    </a:lnB>
+                  </a:tcPr>
+                </a:tc>
+                <a:tc>
+                  <a:txBody>
+                    <a:bodyPr/>
+                    <a:lstStyle/>
+                    <a:p>
+                      <a:pPr marL="0" indent="0">
+                        <a:buNone/>
+                      </a:pPr>
+                      <a:r>
+                        <a:rPr lang="en-US" sz="1050" dirty="0">
+                          <a:solidFill>
+                            <a:srgbClr val="16181D"/>
+                          </a:solidFill>
+                          <a:latin typeface="Calibri" pitchFamily="34" charset="0"/>
+                          <a:ea typeface="Calibri" pitchFamily="34" charset="-122"/>
+                          <a:cs typeface="Calibri" pitchFamily="34" charset="-120"/>
+                        </a:rPr>
+                        <a:t>Weekly. On site in Phoenix for onboarding and training, remote otherwise.</a:t>
+                      </a:r>
+                      <a:endParaRPr lang="en-US" sz="1100" dirty="0">
+                        <a:latin typeface="Calibri" charset="0"/>
+                        <a:ea typeface="Calibri" charset="0"/>
+                        <a:cs typeface="Calibri" charset="0"/>
+                      </a:endParaRPr>
+                    </a:p>
+                  </a:txBody>
+                  <a:tcPr marL="88900" marR="88900" marT="63500" marB="63500">
+                    <a:lnL w="9525" cap="flat" cmpd="sng" algn="ctr">
+                      <a:solidFill>
+                        <a:srgbClr val="D5D9E0"/>
+                      </a:solidFill>
+                      <a:prstDash val="solid"/>
+                      <a:round/>
+                      <a:headEnd type="none" w="med" len="med"/>
+                      <a:tailEnd type="none" w="med" len="med"/>
+                    </a:lnL>
+                    <a:lnR w="9525" cap="flat" cmpd="sng" algn="ctr">
+                      <a:solidFill>
+                        <a:srgbClr val="D5D9E0"/>
+                      </a:solidFill>
+                      <a:prstDash val="solid"/>
+                      <a:round/>
+                      <a:headEnd type="none" w="med" len="med"/>
+                      <a:tailEnd type="none" w="med" len="med"/>
+                    </a:lnR>
+                    <a:lnT w="9525" cap="flat" cmpd="sng" algn="ctr">
+                      <a:solidFill>
+                        <a:srgbClr val="D5D9E0"/>
+                      </a:solidFill>
+                      <a:prstDash val="solid"/>
+                      <a:round/>
+                      <a:headEnd type="none" w="med" len="med"/>
+                      <a:tailEnd type="none" w="med" len="med"/>
+                    </a:lnT>
+                    <a:lnB w="9525" cap="flat" cmpd="sng" algn="ctr">
+                      <a:solidFill>
+                        <a:srgbClr val="D5D9E0"/>
+                      </a:solidFill>
+                      <a:prstDash val="solid"/>
+                      <a:round/>
+                      <a:headEnd type="none" w="med" len="med"/>
+                      <a:tailEnd type="none" w="med" len="med"/>
+                    </a:lnB>
+                  </a:tcPr>
+                </a:tc>
+                <a:extLst>
+                  <a:ext uri="{0D108BD9-81ED-4DB2-BD59-A6C34878D82A}">
+                    <a16:rowId xmlns:a16="http://schemas.microsoft.com/office/drawing/2014/main" val="10003"/>
+                  </a:ext>
+                </a:extLst>
+              </a:tr>
+              <a:tr h="548640">
+                <a:tc>
+                  <a:txBody>
+                    <a:bodyPr/>
+                    <a:lstStyle/>
+                    <a:p>
+                      <a:pPr marL="0" indent="0">
+                        <a:buNone/>
+                      </a:pPr>
+                      <a:r>
+                        <a:rPr lang="en-US" sz="1050" b="1" dirty="0">
                           <a:solidFill>
                             <a:srgbClr val="16181D"/>
                           </a:solidFill>
@@ -12475,7 +12993,7 @@
                         <a:buNone/>
                       </a:pPr>
                       <a:r>
-                        <a:rPr lang="en-US" sz="1100" b="1" dirty="0">
+                        <a:rPr lang="en-US" sz="1050" b="1" dirty="0">
                           <a:solidFill>
                             <a:srgbClr val="16181D"/>
                           </a:solidFill>
@@ -12540,7 +13058,7 @@
                         <a:buNone/>
                       </a:pPr>
                       <a:r>
-                        <a:rPr lang="en-US" sz="1100" dirty="0">
+                        <a:rPr lang="en-US" sz="1050" dirty="0">
                           <a:solidFill>
                             <a:srgbClr val="16181D"/>
                           </a:solidFill>
@@ -12605,7 +13123,7 @@
                         <a:buNone/>
                       </a:pPr>
                       <a:r>
-                        <a:rPr lang="en-US" sz="1100" dirty="0">
+                        <a:rPr lang="en-US" sz="1050" dirty="0">
                           <a:solidFill>
                             <a:srgbClr val="16181D"/>
                           </a:solidFill>
@@ -12670,7 +13188,7 @@
                         <a:buNone/>
                       </a:pPr>
                       <a:r>
-                        <a:rPr lang="en-US" sz="1100" dirty="0">
+                        <a:rPr lang="en-US" sz="1050" dirty="0">
                           <a:solidFill>
                             <a:srgbClr val="16181D"/>
                           </a:solidFill>
@@ -12728,11 +13246,11 @@
                 </a:tc>
                 <a:extLst>
                   <a:ext uri="{0D108BD9-81ED-4DB2-BD59-A6C34878D82A}">
-                    <a16:rowId xmlns:a16="http://schemas.microsoft.com/office/drawing/2014/main" val="10002"/>
+                    <a16:rowId xmlns:a16="http://schemas.microsoft.com/office/drawing/2014/main" val="10004"/>
                   </a:ext>
                 </a:extLst>
               </a:tr>
-              <a:tr h="868680">
+              <a:tr h="548640">
                 <a:tc>
                   <a:txBody>
                     <a:bodyPr/>
@@ -12742,295 +13260,7 @@
                         <a:buNone/>
                       </a:pPr>
                       <a:r>
-                        <a:rPr lang="en-US" sz="1100" b="1" dirty="0">
-                          <a:solidFill>
-                            <a:srgbClr val="16181D"/>
-                          </a:solidFill>
-                          <a:latin typeface="Calibri" pitchFamily="34" charset="0"/>
-                          <a:ea typeface="Calibri" pitchFamily="34" charset="-122"/>
-                          <a:cs typeface="Calibri" pitchFamily="34" charset="-120"/>
-                        </a:rPr>
-                        <a:t>ONYX Controller</a:t>
-                      </a:r>
-                      <a:endParaRPr lang="en-US" sz="1100" dirty="0">
-                        <a:latin typeface="Calibri" charset="0"/>
-                        <a:ea typeface="Calibri" charset="0"/>
-                        <a:cs typeface="Calibri" charset="0"/>
-                      </a:endParaRPr>
-                    </a:p>
-                    <a:p>
-                      <a:pPr marL="0" indent="0">
-                        <a:buNone/>
-                      </a:pPr>
-                      <a:r>
-                        <a:rPr lang="en-US" sz="1100" b="1" dirty="0">
-                          <a:solidFill>
-                            <a:srgbClr val="16181D"/>
-                          </a:solidFill>
-                          <a:latin typeface="Calibri" pitchFamily="34" charset="0"/>
-                          <a:ea typeface="Calibri" pitchFamily="34" charset="-122"/>
-                          <a:cs typeface="Calibri" pitchFamily="34" charset="-120"/>
-                        </a:rPr>
-                        <a:t>To be named at kickoff</a:t>
-                      </a:r>
-                      <a:endParaRPr lang="en-US" sz="1100" dirty="0">
-                        <a:latin typeface="Calibri" charset="0"/>
-                        <a:ea typeface="Calibri" charset="0"/>
-                        <a:cs typeface="Calibri" charset="0"/>
-                      </a:endParaRPr>
-                    </a:p>
-                  </a:txBody>
-                  <a:tcPr marL="88900" marR="88900" marT="63500" marB="63500">
-                    <a:lnL w="9525" cap="flat" cmpd="sng" algn="ctr">
-                      <a:solidFill>
-                        <a:srgbClr val="D5D9E0"/>
-                      </a:solidFill>
-                      <a:prstDash val="solid"/>
-                      <a:round/>
-                      <a:headEnd type="none" w="med" len="med"/>
-                      <a:tailEnd type="none" w="med" len="med"/>
-                    </a:lnL>
-                    <a:lnR w="9525" cap="flat" cmpd="sng" algn="ctr">
-                      <a:solidFill>
-                        <a:srgbClr val="D5D9E0"/>
-                      </a:solidFill>
-                      <a:prstDash val="solid"/>
-                      <a:round/>
-                      <a:headEnd type="none" w="med" len="med"/>
-                      <a:tailEnd type="none" w="med" len="med"/>
-                    </a:lnR>
-                    <a:lnT w="9525" cap="flat" cmpd="sng" algn="ctr">
-                      <a:solidFill>
-                        <a:srgbClr val="D5D9E0"/>
-                      </a:solidFill>
-                      <a:prstDash val="solid"/>
-                      <a:round/>
-                      <a:headEnd type="none" w="med" len="med"/>
-                      <a:tailEnd type="none" w="med" len="med"/>
-                    </a:lnT>
-                    <a:lnB w="9525" cap="flat" cmpd="sng" algn="ctr">
-                      <a:solidFill>
-                        <a:srgbClr val="D5D9E0"/>
-                      </a:solidFill>
-                      <a:prstDash val="solid"/>
-                      <a:round/>
-                      <a:headEnd type="none" w="med" len="med"/>
-                      <a:tailEnd type="none" w="med" len="med"/>
-                    </a:lnB>
-                  </a:tcPr>
-                </a:tc>
-                <a:tc>
-                  <a:txBody>
-                    <a:bodyPr/>
-                    <a:lstStyle/>
-                    <a:p>
-                      <a:pPr marL="0" indent="0">
-                        <a:buNone/>
-                      </a:pPr>
-                      <a:r>
-                        <a:rPr lang="en-US" sz="1100" dirty="0">
-                          <a:solidFill>
-                            <a:srgbClr val="16181D"/>
-                          </a:solidFill>
-                          <a:latin typeface="Calibri" pitchFamily="34" charset="0"/>
-                          <a:ea typeface="Calibri" pitchFamily="34" charset="-122"/>
-                          <a:cs typeface="Calibri" pitchFamily="34" charset="-120"/>
-                        </a:rPr>
-                        <a:t>ONYX controller</a:t>
-                      </a:r>
-                      <a:endParaRPr lang="en-US" sz="1100" dirty="0">
-                        <a:latin typeface="Calibri" charset="0"/>
-                        <a:ea typeface="Calibri" charset="0"/>
-                        <a:cs typeface="Calibri" charset="0"/>
-                      </a:endParaRPr>
-                    </a:p>
-                  </a:txBody>
-                  <a:tcPr marL="88900" marR="88900" marT="63500" marB="63500">
-                    <a:lnL w="9525" cap="flat" cmpd="sng" algn="ctr">
-                      <a:solidFill>
-                        <a:srgbClr val="D5D9E0"/>
-                      </a:solidFill>
-                      <a:prstDash val="solid"/>
-                      <a:round/>
-                      <a:headEnd type="none" w="med" len="med"/>
-                      <a:tailEnd type="none" w="med" len="med"/>
-                    </a:lnL>
-                    <a:lnR w="9525" cap="flat" cmpd="sng" algn="ctr">
-                      <a:solidFill>
-                        <a:srgbClr val="D5D9E0"/>
-                      </a:solidFill>
-                      <a:prstDash val="solid"/>
-                      <a:round/>
-                      <a:headEnd type="none" w="med" len="med"/>
-                      <a:tailEnd type="none" w="med" len="med"/>
-                    </a:lnR>
-                    <a:lnT w="9525" cap="flat" cmpd="sng" algn="ctr">
-                      <a:solidFill>
-                        <a:srgbClr val="D5D9E0"/>
-                      </a:solidFill>
-                      <a:prstDash val="solid"/>
-                      <a:round/>
-                      <a:headEnd type="none" w="med" len="med"/>
-                      <a:tailEnd type="none" w="med" len="med"/>
-                    </a:lnT>
-                    <a:lnB w="9525" cap="flat" cmpd="sng" algn="ctr">
-                      <a:solidFill>
-                        <a:srgbClr val="D5D9E0"/>
-                      </a:solidFill>
-                      <a:prstDash val="solid"/>
-                      <a:round/>
-                      <a:headEnd type="none" w="med" len="med"/>
-                      <a:tailEnd type="none" w="med" len="med"/>
-                    </a:lnB>
-                  </a:tcPr>
-                </a:tc>
-                <a:tc>
-                  <a:txBody>
-                    <a:bodyPr/>
-                    <a:lstStyle/>
-                    <a:p>
-                      <a:pPr marL="0" indent="0">
-                        <a:buNone/>
-                      </a:pPr>
-                      <a:r>
-                        <a:rPr lang="en-US" sz="1100" dirty="0">
-                          <a:solidFill>
-                            <a:srgbClr val="16181D"/>
-                          </a:solidFill>
-                          <a:latin typeface="Calibri" pitchFamily="34" charset="0"/>
-                          <a:ea typeface="Calibri" pitchFamily="34" charset="-122"/>
-                          <a:cs typeface="Calibri" pitchFamily="34" charset="-120"/>
-                        </a:rPr>
-                        <a:t>Leads the monthly close, reviews the internal team's reconciliations and entries, supports physician compensation and revenue-cycle reporting, and drives the systems and automation work.</a:t>
-                      </a:r>
-                      <a:endParaRPr lang="en-US" sz="1100" dirty="0">
-                        <a:latin typeface="Calibri" charset="0"/>
-                        <a:ea typeface="Calibri" charset="0"/>
-                        <a:cs typeface="Calibri" charset="0"/>
-                      </a:endParaRPr>
-                    </a:p>
-                  </a:txBody>
-                  <a:tcPr marL="88900" marR="88900" marT="63500" marB="63500">
-                    <a:lnL w="9525" cap="flat" cmpd="sng" algn="ctr">
-                      <a:solidFill>
-                        <a:srgbClr val="D5D9E0"/>
-                      </a:solidFill>
-                      <a:prstDash val="solid"/>
-                      <a:round/>
-                      <a:headEnd type="none" w="med" len="med"/>
-                      <a:tailEnd type="none" w="med" len="med"/>
-                    </a:lnL>
-                    <a:lnR w="9525" cap="flat" cmpd="sng" algn="ctr">
-                      <a:solidFill>
-                        <a:srgbClr val="D5D9E0"/>
-                      </a:solidFill>
-                      <a:prstDash val="solid"/>
-                      <a:round/>
-                      <a:headEnd type="none" w="med" len="med"/>
-                      <a:tailEnd type="none" w="med" len="med"/>
-                    </a:lnR>
-                    <a:lnT w="9525" cap="flat" cmpd="sng" algn="ctr">
-                      <a:solidFill>
-                        <a:srgbClr val="D5D9E0"/>
-                      </a:solidFill>
-                      <a:prstDash val="solid"/>
-                      <a:round/>
-                      <a:headEnd type="none" w="med" len="med"/>
-                      <a:tailEnd type="none" w="med" len="med"/>
-                    </a:lnT>
-                    <a:lnB w="9525" cap="flat" cmpd="sng" algn="ctr">
-                      <a:solidFill>
-                        <a:srgbClr val="D5D9E0"/>
-                      </a:solidFill>
-                      <a:prstDash val="solid"/>
-                      <a:round/>
-                      <a:headEnd type="none" w="med" len="med"/>
-                      <a:tailEnd type="none" w="med" len="med"/>
-                    </a:lnB>
-                  </a:tcPr>
-                </a:tc>
-                <a:tc>
-                  <a:txBody>
-                    <a:bodyPr/>
-                    <a:lstStyle/>
-                    <a:p>
-                      <a:pPr marL="0" indent="0">
-                        <a:buNone/>
-                      </a:pPr>
-                      <a:r>
-                        <a:rPr lang="en-US" sz="1100" dirty="0">
-                          <a:solidFill>
-                            <a:srgbClr val="16181D"/>
-                          </a:solidFill>
-                          <a:latin typeface="Calibri" pitchFamily="34" charset="0"/>
-                          <a:ea typeface="Calibri" pitchFamily="34" charset="-122"/>
-                          <a:cs typeface="Calibri" pitchFamily="34" charset="-120"/>
-                        </a:rPr>
-                        <a:t>Weekly. On site in Phoenix for onboarding and training, remote otherwise.</a:t>
-                      </a:r>
-                      <a:endParaRPr lang="en-US" sz="1100" dirty="0">
-                        <a:latin typeface="Calibri" charset="0"/>
-                        <a:ea typeface="Calibri" charset="0"/>
-                        <a:cs typeface="Calibri" charset="0"/>
-                      </a:endParaRPr>
-                    </a:p>
-                  </a:txBody>
-                  <a:tcPr marL="88900" marR="88900" marT="63500" marB="63500">
-                    <a:lnL w="9525" cap="flat" cmpd="sng" algn="ctr">
-                      <a:solidFill>
-                        <a:srgbClr val="D5D9E0"/>
-                      </a:solidFill>
-                      <a:prstDash val="solid"/>
-                      <a:round/>
-                      <a:headEnd type="none" w="med" len="med"/>
-                      <a:tailEnd type="none" w="med" len="med"/>
-                    </a:lnL>
-                    <a:lnR w="9525" cap="flat" cmpd="sng" algn="ctr">
-                      <a:solidFill>
-                        <a:srgbClr val="D5D9E0"/>
-                      </a:solidFill>
-                      <a:prstDash val="solid"/>
-                      <a:round/>
-                      <a:headEnd type="none" w="med" len="med"/>
-                      <a:tailEnd type="none" w="med" len="med"/>
-                    </a:lnR>
-                    <a:lnT w="9525" cap="flat" cmpd="sng" algn="ctr">
-                      <a:solidFill>
-                        <a:srgbClr val="D5D9E0"/>
-                      </a:solidFill>
-                      <a:prstDash val="solid"/>
-                      <a:round/>
-                      <a:headEnd type="none" w="med" len="med"/>
-                      <a:tailEnd type="none" w="med" len="med"/>
-                    </a:lnT>
-                    <a:lnB w="9525" cap="flat" cmpd="sng" algn="ctr">
-                      <a:solidFill>
-                        <a:srgbClr val="D5D9E0"/>
-                      </a:solidFill>
-                      <a:prstDash val="solid"/>
-                      <a:round/>
-                      <a:headEnd type="none" w="med" len="med"/>
-                      <a:tailEnd type="none" w="med" len="med"/>
-                    </a:lnB>
-                  </a:tcPr>
-                </a:tc>
-                <a:extLst>
-                  <a:ext uri="{0D108BD9-81ED-4DB2-BD59-A6C34878D82A}">
-                    <a16:rowId xmlns:a16="http://schemas.microsoft.com/office/drawing/2014/main" val="10003"/>
-                  </a:ext>
-                </a:extLst>
-              </a:tr>
-              <a:tr h="685800">
-                <a:tc>
-                  <a:txBody>
-                    <a:bodyPr/>
-                    <a:lstStyle/>
-                    <a:p>
-                      <a:pPr marL="0" indent="0">
-                        <a:buNone/>
-                      </a:pPr>
-                      <a:r>
-                        <a:rPr lang="en-US" sz="1100" b="1" dirty="0">
+                        <a:rPr lang="en-US" sz="1050" b="1" dirty="0">
                           <a:solidFill>
                             <a:srgbClr val="16181D"/>
                           </a:solidFill>
@@ -13095,7 +13325,7 @@
                         <a:buNone/>
                       </a:pPr>
                       <a:r>
-                        <a:rPr lang="en-US" sz="1100" dirty="0">
+                        <a:rPr lang="en-US" sz="1050" dirty="0">
                           <a:solidFill>
                             <a:srgbClr val="16181D"/>
                           </a:solidFill>
@@ -13160,7 +13390,7 @@
                         <a:buNone/>
                       </a:pPr>
                       <a:r>
-                        <a:rPr lang="en-US" sz="1100" dirty="0">
+                        <a:rPr lang="en-US" sz="1050" dirty="0">
                           <a:solidFill>
                             <a:srgbClr val="16181D"/>
                           </a:solidFill>
@@ -13225,7 +13455,7 @@
                         <a:buNone/>
                       </a:pPr>
                       <a:r>
-                        <a:rPr lang="en-US" sz="1100" dirty="0">
+                        <a:rPr lang="en-US" sz="1050" dirty="0">
                           <a:solidFill>
                             <a:srgbClr val="16181D"/>
                           </a:solidFill>
@@ -13631,7 +13861,7 @@
                   <a:schemeClr val="tx1"/>
                 </a:solidFill>
               </a:rPr>
-              <a:t>Mark Williamson, in transition. A supervisory accountant, three staff and an international AP resource.</a:t>
+              <a:t>Mark Williamson, CFO, retiring. A supervisory accountant, three staff and an international AP resource.</a:t>
             </a:r>
             <a:endParaRPr lang="en-US" sz="1150" dirty="0"/>
           </a:p>
@@ -13962,7 +14192,7 @@
                   <a:schemeClr val="tx1"/>
                 </a:solidFill>
               </a:rPr>
-              <a:t>Controller-led close and operational finance, with knowledge transfer from Mark before he steps away.</a:t>
+              <a:t>Controller-led close and operational finance, with knowledge transfer from Mark before he retires.</a:t>
             </a:r>
             <a:endParaRPr lang="en-US" sz="1150" dirty="0"/>
           </a:p>

</xml_diff>

<commit_message>
Arizona Center for Hand to Shoulder Surgery: use the practice's full-color logo in the proposal
Co-Authored-By: Claude Fable 5.1 <noreply@anthropic.com>
Claude-Session: https://claude.ai/code/session_01KQiKzmv3wJWX8AFkC8re3n
</commit_message>
<xml_diff>
--- a/Onyx_AZHandCenter_Proposal.pptx
+++ b/Onyx_AZHandCenter_Proposal.pptx
@@ -2328,7 +2328,7 @@
       </p:sp>
       <p:pic>
         <p:nvPicPr>
-          <p:cNvPr id="12" name="Client logo" descr="AZHandCenter_navy.png"/>
+          <p:cNvPr id="12" name="Client logo" descr="AZHandCenter.png"/>
           <p:cNvPicPr>
             <a:picLocks noChangeAspect="1"/>
           </p:cNvPicPr>
@@ -2343,7 +2343,7 @@
         <p:spPr>
           <a:xfrm>
             <a:off x="5212080" y="1508760"/>
-            <a:ext cx="4480560" cy="711524"/>
+            <a:ext cx="4480560" cy="916314"/>
           </a:xfrm>
           <a:prstGeom prst="rect">
             <a:avLst/>
@@ -9099,7 +9099,7 @@
       </p:sp>
       <p:pic>
         <p:nvPicPr>
-          <p:cNvPr id="8" name="Client logo" descr="AZHandCenter_navy.png"/>
+          <p:cNvPr id="8" name="Client logo" descr="AZHandCenter.png"/>
           <p:cNvPicPr>
             <a:picLocks noChangeAspect="1"/>
           </p:cNvPicPr>
@@ -9113,8 +9113,8 @@
         </p:blipFill>
         <p:spPr>
           <a:xfrm>
-            <a:off x="8458200" y="2480178"/>
-            <a:ext cx="2834640" cy="450148"/>
+            <a:off x="8458200" y="2415398"/>
+            <a:ext cx="2834640" cy="579709"/>
           </a:xfrm>
           <a:prstGeom prst="rect">
             <a:avLst/>

</xml_diff>

<commit_message>
Arizona Center for Hand to Shoulder Surgery: Steven's updated proposal with the Intuit ProAdvisor Elite badge
Takes Steven's edited copy of the deck (Oct 8 date, team roles, rates) and
adds the Intuit ProAdvisor Elite badge beside the firm paragraph on the Who
we are slide. The proposal-deck builder gains a --badge option for the same
placement.

Co-Authored-By: Claude Fable 5.1 <noreply@anthropic.com>
Claude-Session: https://claude.ai/code/session_01KQiKzmv3wJWX8AFkC8re3n
</commit_message>
<xml_diff>
--- a/Onyx_AZHandCenter_Proposal.pptx
+++ b/Onyx_AZHandCenter_Proposal.pptx
@@ -171,6 +171,103 @@
 </p:presentation>
 </file>
 
+<file path=ppt/changesInfos/changesInfo1.xml><?xml version="1.0" encoding="utf-8"?>
+<pc:chgInfo xmlns:a="http://schemas.openxmlformats.org/drawingml/2006/main" xmlns:r="http://schemas.openxmlformats.org/officeDocument/2006/relationships" xmlns:ac="http://schemas.microsoft.com/office/drawing/2013/main/command" xmlns:pc="http://schemas.microsoft.com/office/powerpoint/2013/main/command">
+  <pc:docChgLst>
+    <pc:chgData name="Steven Nikolov" userId="fd889f8a-aeec-4bc4-ba43-666f47c9a6f3" providerId="ADAL" clId="{ACDA49B6-FD16-4D95-A971-92F38B31E145}"/>
+    <pc:docChg chg="modSld">
+      <pc:chgData name="Steven Nikolov" userId="fd889f8a-aeec-4bc4-ba43-666f47c9a6f3" providerId="ADAL" clId="{ACDA49B6-FD16-4D95-A971-92F38B31E145}" dt="2026-10-08T17:42:08.724" v="85" actId="20577"/>
+      <pc:docMkLst>
+        <pc:docMk/>
+      </pc:docMkLst>
+      <pc:sldChg chg="modSp mod">
+        <pc:chgData name="Steven Nikolov" userId="fd889f8a-aeec-4bc4-ba43-666f47c9a6f3" providerId="ADAL" clId="{ACDA49B6-FD16-4D95-A971-92F38B31E145}" dt="2026-10-08T17:42:08.724" v="85" actId="20577"/>
+        <pc:sldMkLst>
+          <pc:docMk/>
+          <pc:sldMk cId="0" sldId="257"/>
+        </pc:sldMkLst>
+        <pc:spChg chg="mod">
+          <ac:chgData name="Steven Nikolov" userId="fd889f8a-aeec-4bc4-ba43-666f47c9a6f3" providerId="ADAL" clId="{ACDA49B6-FD16-4D95-A971-92F38B31E145}" dt="2026-10-08T17:42:08.724" v="85" actId="20577"/>
+          <ac:spMkLst>
+            <pc:docMk/>
+            <pc:sldMk cId="0" sldId="257"/>
+            <ac:spMk id="4" creationId="{00000000-0000-0000-0000-000000000000}"/>
+          </ac:spMkLst>
+        </pc:spChg>
+      </pc:sldChg>
+      <pc:sldChg chg="modSp mod">
+        <pc:chgData name="Steven Nikolov" userId="fd889f8a-aeec-4bc4-ba43-666f47c9a6f3" providerId="ADAL" clId="{ACDA49B6-FD16-4D95-A971-92F38B31E145}" dt="2026-10-08T17:39:21.581" v="27" actId="20577"/>
+        <pc:sldMkLst>
+          <pc:docMk/>
+          <pc:sldMk cId="0" sldId="260"/>
+        </pc:sldMkLst>
+        <pc:graphicFrameChg chg="modGraphic">
+          <ac:chgData name="Steven Nikolov" userId="fd889f8a-aeec-4bc4-ba43-666f47c9a6f3" providerId="ADAL" clId="{ACDA49B6-FD16-4D95-A971-92F38B31E145}" dt="2026-10-08T17:39:21.581" v="27" actId="20577"/>
+          <ac:graphicFrameMkLst>
+            <pc:docMk/>
+            <pc:sldMk cId="0" sldId="260"/>
+            <ac:graphicFrameMk id="6" creationId="{00000000-0000-0000-0000-000000000000}"/>
+          </ac:graphicFrameMkLst>
+        </pc:graphicFrameChg>
+      </pc:sldChg>
+      <pc:sldChg chg="modSp mod">
+        <pc:chgData name="Steven Nikolov" userId="fd889f8a-aeec-4bc4-ba43-666f47c9a6f3" providerId="ADAL" clId="{ACDA49B6-FD16-4D95-A971-92F38B31E145}" dt="2026-10-08T17:39:59.603" v="43" actId="20577"/>
+        <pc:sldMkLst>
+          <pc:docMk/>
+          <pc:sldMk cId="0" sldId="266"/>
+        </pc:sldMkLst>
+        <pc:graphicFrameChg chg="modGraphic">
+          <ac:chgData name="Steven Nikolov" userId="fd889f8a-aeec-4bc4-ba43-666f47c9a6f3" providerId="ADAL" clId="{ACDA49B6-FD16-4D95-A971-92F38B31E145}" dt="2026-10-08T17:39:59.603" v="43" actId="20577"/>
+          <ac:graphicFrameMkLst>
+            <pc:docMk/>
+            <pc:sldMk cId="0" sldId="266"/>
+            <ac:graphicFrameMk id="12" creationId="{00000000-0000-0000-0000-000000000000}"/>
+          </ac:graphicFrameMkLst>
+        </pc:graphicFrameChg>
+      </pc:sldChg>
+      <pc:sldChg chg="modSp mod">
+        <pc:chgData name="Steven Nikolov" userId="fd889f8a-aeec-4bc4-ba43-666f47c9a6f3" providerId="ADAL" clId="{ACDA49B6-FD16-4D95-A971-92F38B31E145}" dt="2026-10-08T17:41:24.125" v="82" actId="20577"/>
+        <pc:sldMkLst>
+          <pc:docMk/>
+          <pc:sldMk cId="0" sldId="267"/>
+        </pc:sldMkLst>
+        <pc:spChg chg="mod">
+          <ac:chgData name="Steven Nikolov" userId="fd889f8a-aeec-4bc4-ba43-666f47c9a6f3" providerId="ADAL" clId="{ACDA49B6-FD16-4D95-A971-92F38B31E145}" dt="2026-10-08T17:41:24.125" v="82" actId="20577"/>
+          <ac:spMkLst>
+            <pc:docMk/>
+            <pc:sldMk cId="0" sldId="267"/>
+            <ac:spMk id="6" creationId="{00000000-0000-0000-0000-000000000000}"/>
+          </ac:spMkLst>
+        </pc:spChg>
+        <pc:graphicFrameChg chg="modGraphic">
+          <ac:chgData name="Steven Nikolov" userId="fd889f8a-aeec-4bc4-ba43-666f47c9a6f3" providerId="ADAL" clId="{ACDA49B6-FD16-4D95-A971-92F38B31E145}" dt="2026-10-08T17:40:17.373" v="50" actId="20577"/>
+          <ac:graphicFrameMkLst>
+            <pc:docMk/>
+            <pc:sldMk cId="0" sldId="267"/>
+            <ac:graphicFrameMk id="13" creationId="{00000000-0000-0000-0000-000000000000}"/>
+          </ac:graphicFrameMkLst>
+        </pc:graphicFrameChg>
+      </pc:sldChg>
+      <pc:sldChg chg="modSp mod">
+        <pc:chgData name="Steven Nikolov" userId="fd889f8a-aeec-4bc4-ba43-666f47c9a6f3" providerId="ADAL" clId="{ACDA49B6-FD16-4D95-A971-92F38B31E145}" dt="2026-10-08T17:41:53.374" v="84" actId="20577"/>
+        <pc:sldMkLst>
+          <pc:docMk/>
+          <pc:sldMk cId="0" sldId="269"/>
+        </pc:sldMkLst>
+        <pc:spChg chg="mod">
+          <ac:chgData name="Steven Nikolov" userId="fd889f8a-aeec-4bc4-ba43-666f47c9a6f3" providerId="ADAL" clId="{ACDA49B6-FD16-4D95-A971-92F38B31E145}" dt="2026-10-08T17:41:53.374" v="84" actId="20577"/>
+          <ac:spMkLst>
+            <pc:docMk/>
+            <pc:sldMk cId="0" sldId="269"/>
+            <ac:spMk id="3" creationId="{00000000-0000-0000-0000-000000000000}"/>
+          </ac:spMkLst>
+        </pc:spChg>
+      </pc:sldChg>
+    </pc:docChg>
+  </pc:docChgLst>
+</pc:chgInfo>
+</file>
+
 <file path=ppt/notesMasters/notesMaster1.xml><?xml version="1.0" encoding="utf-8"?>
 <p:notesMaster xmlns:a="http://schemas.openxmlformats.org/drawingml/2006/main" xmlns:r="http://schemas.openxmlformats.org/officeDocument/2006/relationships" xmlns:p="http://schemas.openxmlformats.org/presentationml/2006/main">
   <p:cSld>
@@ -1751,7 +1848,7 @@
           </a:prstGeom>
           <a:extLst>
             <a:ext uri="{C572A759-6A51-4108-AA02-DFA0A04FC94B}">
-              <ma14:wrappingTextBoxFlag xmlns:ma14="http://schemas.microsoft.com/office/mac/drawingml/2011/main" xmlns="" val="0"/>
+              <ma14:wrappingTextBoxFlag xmlns="" xmlns:ma14="http://schemas.microsoft.com/office/mac/drawingml/2011/main" val="0"/>
             </a:ext>
           </a:extLst>
         </p:spPr>
@@ -1883,7 +1980,7 @@
           </a:prstGeom>
           <a:extLst>
             <a:ext uri="{C572A759-6A51-4108-AA02-DFA0A04FC94B}">
-              <ma14:wrappingTextBoxFlag xmlns:ma14="http://schemas.microsoft.com/office/mac/drawingml/2011/main" xmlns="" val="0"/>
+              <ma14:wrappingTextBoxFlag xmlns="" xmlns:ma14="http://schemas.microsoft.com/office/mac/drawingml/2011/main" val="0"/>
             </a:ext>
           </a:extLst>
         </p:spPr>
@@ -2335,7 +2432,7 @@
           <p:nvPr/>
         </p:nvPicPr>
         <p:blipFill>
-          <a:blip r:embed="rId5"/>
+          <a:blip r:embed="rId4"/>
           <a:stretch>
             <a:fillRect/>
           </a:stretch>
@@ -3947,7 +4044,7 @@
           </a:prstGeom>
           <a:extLst>
             <a:ext uri="{C572A759-6A51-4108-AA02-DFA0A04FC94B}">
-              <ma14:wrappingTextBoxFlag xmlns:ma14="http://schemas.microsoft.com/office/mac/drawingml/2011/main" xmlns="" val="0"/>
+              <ma14:wrappingTextBoxFlag xmlns="" xmlns:ma14="http://schemas.microsoft.com/office/mac/drawingml/2011/main" val="0"/>
             </a:ext>
           </a:extLst>
         </p:spPr>
@@ -4086,14 +4183,14 @@
           <p:nvPr>
             <p:extLst>
               <p:ext uri="{D42A27DB-BD31-4B8C-83A1-F6EECF244321}">
-                <p14:modId xmlns:p14="http://schemas.microsoft.com/office/powerpoint/2010/main" val="1579011935"/>
+                <p14:modId xmlns:p14="http://schemas.microsoft.com/office/powerpoint/2010/main" val="1259807548"/>
               </p:ext>
             </p:extLst>
           </p:nvPr>
         </p:nvGraphicFramePr>
         <p:xfrm>
           <a:off x="548640" y="1600200"/>
-          <a:ext cx="11094415" cy="914400"/>
+          <a:ext cx="11091672" cy="4114800"/>
         </p:xfrm>
         <a:graphic>
           <a:graphicData uri="http://schemas.openxmlformats.org/drawingml/2006/table">
@@ -4556,7 +4653,7 @@
                           <a:ea typeface="Calibri" pitchFamily="34" charset="-122"/>
                           <a:cs typeface="Calibri" pitchFamily="34" charset="-120"/>
                         </a:rPr>
-                        <a:t>Controller</a:t>
+                        <a:t>Controller/CFO</a:t>
                       </a:r>
                       <a:endParaRPr lang="en-US" sz="1100" dirty="0">
                         <a:latin typeface="Calibri" charset="0"/>
@@ -5357,7 +5454,7 @@
                           <a:ea typeface="Calibri" pitchFamily="34" charset="-122"/>
                           <a:cs typeface="Calibri" pitchFamily="34" charset="-120"/>
                         </a:rPr>
-                        <a:t>Controller</a:t>
+                        <a:t>Controller/CFO</a:t>
                       </a:r>
                       <a:endParaRPr lang="en-US" sz="1100" dirty="0">
                         <a:latin typeface="Calibri" charset="0"/>
@@ -5624,7 +5721,7 @@
                           <a:ea typeface="Calibri" pitchFamily="34" charset="-122"/>
                           <a:cs typeface="Calibri" pitchFamily="34" charset="-120"/>
                         </a:rPr>
-                        <a:t>Controller</a:t>
+                        <a:t>Controller/CFO</a:t>
                       </a:r>
                       <a:endParaRPr lang="en-US" sz="1100" dirty="0">
                         <a:latin typeface="Calibri" charset="0"/>
@@ -5891,7 +5988,7 @@
                           <a:ea typeface="Calibri" pitchFamily="34" charset="-122"/>
                           <a:cs typeface="Calibri" pitchFamily="34" charset="-120"/>
                         </a:rPr>
-                        <a:t>Controller</a:t>
+                        <a:t>Controller/CFO</a:t>
                       </a:r>
                       <a:endParaRPr lang="en-US" sz="1100" dirty="0">
                         <a:latin typeface="Calibri" charset="0"/>
@@ -6070,7 +6167,7 @@
           </a:prstGeom>
           <a:extLst>
             <a:ext uri="{C572A759-6A51-4108-AA02-DFA0A04FC94B}">
-              <ma14:wrappingTextBoxFlag xmlns:ma14="http://schemas.microsoft.com/office/mac/drawingml/2011/main" xmlns="" val="0"/>
+              <ma14:wrappingTextBoxFlag xmlns="" xmlns:ma14="http://schemas.microsoft.com/office/mac/drawingml/2011/main" val="0"/>
             </a:ext>
           </a:extLst>
         </p:spPr>
@@ -6245,14 +6342,14 @@
           <p:nvPr>
             <p:extLst>
               <p:ext uri="{D42A27DB-BD31-4B8C-83A1-F6EECF244321}">
-                <p14:modId xmlns:p14="http://schemas.microsoft.com/office/powerpoint/2010/main" val="1579011935"/>
+                <p14:modId xmlns:p14="http://schemas.microsoft.com/office/powerpoint/2010/main" val="496249820"/>
               </p:ext>
             </p:extLst>
           </p:nvPr>
         </p:nvGraphicFramePr>
         <p:xfrm>
           <a:off x="548640" y="2103120"/>
-          <a:ext cx="6766560" cy="914400"/>
+          <a:ext cx="6766560" cy="2560320"/>
         </p:xfrm>
         <a:graphic>
           <a:graphicData uri="http://schemas.openxmlformats.org/drawingml/2006/table">
@@ -6575,7 +6672,7 @@
                           <a:ea typeface="Calibri" pitchFamily="34" charset="-122"/>
                           <a:cs typeface="Calibri" pitchFamily="34" charset="-120"/>
                         </a:rPr>
-                        <a:t>$100</a:t>
+                        <a:t>$95</a:t>
                       </a:r>
                       <a:endParaRPr lang="en-US" sz="1600" dirty="0">
                         <a:latin typeface="Calibri" charset="0"/>
@@ -6777,7 +6874,7 @@
                           <a:ea typeface="Calibri" pitchFamily="34" charset="-122"/>
                           <a:cs typeface="Calibri" pitchFamily="34" charset="-120"/>
                         </a:rPr>
-                        <a:t>$185</a:t>
+                        <a:t>$195</a:t>
                       </a:r>
                       <a:endParaRPr lang="en-US" sz="1600" dirty="0">
                         <a:latin typeface="Calibri" charset="0"/>
@@ -6979,7 +7076,7 @@
                           <a:ea typeface="Calibri" pitchFamily="34" charset="-122"/>
                           <a:cs typeface="Calibri" pitchFamily="34" charset="-120"/>
                         </a:rPr>
-                        <a:t>$250</a:t>
+                        <a:t>$295</a:t>
                       </a:r>
                       <a:endParaRPr lang="en-US" sz="1600" dirty="0">
                         <a:latin typeface="Calibri" charset="0"/>
@@ -7132,7 +7229,7 @@
                   <a:schemeClr val="accent3"/>
                 </a:solidFill>
               </a:rPr>
-              <a:t>Rates are guaranteed through December 31, 2026. After that date, rates change only as agreed in writing.</a:t>
+              <a:t>Rates are reviewed annually and guaranteed through December 31, 2027. After that date, rates change only as agreed in writing.</a:t>
             </a:r>
             <a:endParaRPr lang="en-US" sz="1100" dirty="0"/>
           </a:p>
@@ -7514,7 +7611,7 @@
           </a:prstGeom>
           <a:extLst>
             <a:ext uri="{C572A759-6A51-4108-AA02-DFA0A04FC94B}">
-              <ma14:wrappingTextBoxFlag xmlns:ma14="http://schemas.microsoft.com/office/mac/drawingml/2011/main" xmlns="" val="0"/>
+              <ma14:wrappingTextBoxFlag xmlns="" xmlns:ma14="http://schemas.microsoft.com/office/mac/drawingml/2011/main" val="0"/>
             </a:ext>
           </a:extLst>
         </p:spPr>
@@ -8850,7 +8947,7 @@
           </a:prstGeom>
           <a:extLst>
             <a:ext uri="{C572A759-6A51-4108-AA02-DFA0A04FC94B}">
-              <ma14:wrappingTextBoxFlag xmlns:ma14="http://schemas.microsoft.com/office/mac/drawingml/2011/main" xmlns="" val="0"/>
+              <ma14:wrappingTextBoxFlag xmlns="" xmlns:ma14="http://schemas.microsoft.com/office/mac/drawingml/2011/main" val="0"/>
             </a:ext>
           </a:extLst>
         </p:spPr>
@@ -8969,7 +9066,7 @@
                   <a:schemeClr val="bg1"/>
                 </a:solidFill>
               </a:rPr>
-              <a:t>We appreciate the opportunity to earn the practice's business and to become a trusted partner to the physicians.</a:t>
+              <a:t>We appreciate the opportunity to earn the practice's business and to become a trusted partner to the Physicians.</a:t>
             </a:r>
             <a:endParaRPr lang="en-US" sz="1400" dirty="0"/>
           </a:p>
@@ -9106,7 +9203,7 @@
           <p:nvPr/>
         </p:nvPicPr>
         <p:blipFill>
-          <a:blip r:embed="rId4"/>
+          <a:blip r:embed="rId3"/>
           <a:stretch>
             <a:fillRect/>
           </a:stretch>
@@ -9323,7 +9420,7 @@
                   <a:schemeClr val="accent3"/>
                 </a:solidFill>
               </a:rPr>
-              <a:t>October 7, 2026</a:t>
+              <a:t>October 8, 2026</a:t>
             </a:r>
             <a:endParaRPr lang="en-US" sz="1200" dirty="0"/>
           </a:p>
@@ -9598,7 +9695,7 @@
           </a:prstGeom>
           <a:extLst>
             <a:ext uri="{C572A759-6A51-4108-AA02-DFA0A04FC94B}">
-              <ma14:wrappingTextBoxFlag xmlns:ma14="http://schemas.microsoft.com/office/mac/drawingml/2011/main" xmlns="" val="0"/>
+              <ma14:wrappingTextBoxFlag xmlns="" xmlns:ma14="http://schemas.microsoft.com/office/mac/drawingml/2011/main" val="0"/>
             </a:ext>
           </a:extLst>
         </p:spPr>
@@ -10624,7 +10721,7 @@
           </a:prstGeom>
           <a:extLst>
             <a:ext uri="{C572A759-6A51-4108-AA02-DFA0A04FC94B}">
-              <ma14:wrappingTextBoxFlag xmlns:ma14="http://schemas.microsoft.com/office/mac/drawingml/2011/main" xmlns="" val="0"/>
+              <ma14:wrappingTextBoxFlag xmlns="" xmlns:ma14="http://schemas.microsoft.com/office/mac/drawingml/2011/main" val="0"/>
             </a:ext>
           </a:extLst>
         </p:spPr>
@@ -10763,7 +10860,7 @@
         <p:spPr>
           <a:xfrm>
             <a:off x="548640" y="1600200"/>
-            <a:ext cx="5486400" cy="1554480"/>
+            <a:ext cx="4526280" cy="1554480"/>
           </a:xfrm>
           <a:prstGeom prst="rect">
             <a:avLst/>
@@ -11601,7 +11698,7 @@
           </a:prstGeom>
           <a:extLst>
             <a:ext uri="{C572A759-6A51-4108-AA02-DFA0A04FC94B}">
-              <ma14:wrappingTextBoxFlag xmlns:ma14="http://schemas.microsoft.com/office/mac/drawingml/2011/main" xmlns="" val="0"/>
+              <ma14:wrappingTextBoxFlag xmlns="" xmlns:ma14="http://schemas.microsoft.com/office/mac/drawingml/2011/main" val="0"/>
             </a:ext>
           </a:extLst>
         </p:spPr>
@@ -11626,6 +11723,30 @@
           </a:p>
         </p:txBody>
       </p:sp>
+      <p:pic>
+        <p:nvPicPr>
+          <p:cNvPr id="28" name="Intuit ProAdvisor Elite badge" descr="Intuit_ProAdvisor_Elite.png"/>
+          <p:cNvPicPr>
+            <a:picLocks noChangeAspect="1"/>
+          </p:cNvPicPr>
+          <p:nvPr/>
+        </p:nvPicPr>
+        <p:blipFill>
+          <a:blip r:embed="rId3"/>
+          <a:stretch>
+            <a:fillRect/>
+          </a:stretch>
+        </p:blipFill>
+        <p:spPr>
+          <a:xfrm>
+            <a:off x="5257800" y="1572768"/>
+            <a:ext cx="888547" cy="960120"/>
+          </a:xfrm>
+          <a:prstGeom prst="rect">
+            <a:avLst/>
+          </a:prstGeom>
+        </p:spPr>
+      </p:pic>
     </p:spTree>
   </p:cSld>
   <p:clrMapOvr>
@@ -11776,14 +11897,14 @@
           <p:nvPr>
             <p:extLst>
               <p:ext uri="{D42A27DB-BD31-4B8C-83A1-F6EECF244321}">
-                <p14:modId xmlns:p14="http://schemas.microsoft.com/office/powerpoint/2010/main" val="1913832357"/>
+                <p14:modId xmlns:p14="http://schemas.microsoft.com/office/powerpoint/2010/main" val="3685566062"/>
               </p:ext>
             </p:extLst>
           </p:nvPr>
         </p:nvGraphicFramePr>
         <p:xfrm>
           <a:off x="548640" y="2057400"/>
-          <a:ext cx="11091672" cy="3108960"/>
+          <a:ext cx="11091672" cy="3342640"/>
         </p:xfrm>
         <a:graphic>
           <a:graphicData uri="http://schemas.openxmlformats.org/drawingml/2006/table">
@@ -12202,7 +12323,7 @@
                           <a:ea typeface="Calibri" pitchFamily="34" charset="-122"/>
                           <a:cs typeface="Calibri" pitchFamily="34" charset="-120"/>
                         </a:rPr>
-                        <a:t>Relationship lead and CFO</a:t>
+                        <a:t>Relationship lead</a:t>
                       </a:r>
                       <a:endParaRPr lang="en-US" sz="1100" dirty="0">
                         <a:latin typeface="Calibri" charset="0"/>
@@ -12490,7 +12611,7 @@
                           <a:ea typeface="Calibri" pitchFamily="34" charset="-122"/>
                           <a:cs typeface="Calibri" pitchFamily="34" charset="-120"/>
                         </a:rPr>
-                        <a:t>CFO support</a:t>
+                        <a:t>CFO</a:t>
                       </a:r>
                       <a:endParaRPr lang="en-US" sz="1100" dirty="0">
                         <a:latin typeface="Calibri" charset="0"/>
@@ -12778,7 +12899,7 @@
                           <a:ea typeface="Calibri" pitchFamily="34" charset="-122"/>
                           <a:cs typeface="Calibri" pitchFamily="34" charset="-120"/>
                         </a:rPr>
-                        <a:t>ONYX controller</a:t>
+                        <a:t>Controller</a:t>
                       </a:r>
                       <a:endParaRPr lang="en-US" sz="1100" dirty="0">
                         <a:latin typeface="Calibri" charset="0"/>
@@ -13513,7 +13634,7 @@
                 </a:tc>
                 <a:extLst>
                   <a:ext uri="{0D108BD9-81ED-4DB2-BD59-A6C34878D82A}">
-                    <a16:rowId xmlns:a16="http://schemas.microsoft.com/office/drawing/2014/main" val="10004"/>
+                    <a16:rowId xmlns:a16="http://schemas.microsoft.com/office/drawing/2014/main" val="1229150228"/>
                   </a:ext>
                 </a:extLst>
               </a:tr>
@@ -13577,7 +13698,7 @@
           </a:prstGeom>
           <a:extLst>
             <a:ext uri="{C572A759-6A51-4108-AA02-DFA0A04FC94B}">
-              <ma14:wrappingTextBoxFlag xmlns:ma14="http://schemas.microsoft.com/office/mac/drawingml/2011/main" xmlns="" val="0"/>
+              <ma14:wrappingTextBoxFlag xmlns="" xmlns:ma14="http://schemas.microsoft.com/office/mac/drawingml/2011/main" val="0"/>
             </a:ext>
           </a:extLst>
         </p:spPr>
@@ -15125,7 +15246,7 @@
           </a:prstGeom>
           <a:extLst>
             <a:ext uri="{C572A759-6A51-4108-AA02-DFA0A04FC94B}">
-              <ma14:wrappingTextBoxFlag xmlns:ma14="http://schemas.microsoft.com/office/mac/drawingml/2011/main" xmlns="" val="0"/>
+              <ma14:wrappingTextBoxFlag xmlns="" xmlns:ma14="http://schemas.microsoft.com/office/mac/drawingml/2011/main" val="0"/>
             </a:ext>
           </a:extLst>
         </p:spPr>
@@ -16154,7 +16275,7 @@
           </a:prstGeom>
           <a:extLst>
             <a:ext uri="{C572A759-6A51-4108-AA02-DFA0A04FC94B}">
-              <ma14:wrappingTextBoxFlag xmlns:ma14="http://schemas.microsoft.com/office/mac/drawingml/2011/main" xmlns="" val="0"/>
+              <ma14:wrappingTextBoxFlag xmlns="" xmlns:ma14="http://schemas.microsoft.com/office/mac/drawingml/2011/main" val="0"/>
             </a:ext>
           </a:extLst>
         </p:spPr>
@@ -16983,7 +17104,7 @@
           </a:prstGeom>
           <a:extLst>
             <a:ext uri="{C572A759-6A51-4108-AA02-DFA0A04FC94B}">
-              <ma14:wrappingTextBoxFlag xmlns:ma14="http://schemas.microsoft.com/office/mac/drawingml/2011/main" xmlns="" val="0"/>
+              <ma14:wrappingTextBoxFlag xmlns="" xmlns:ma14="http://schemas.microsoft.com/office/mac/drawingml/2011/main" val="0"/>
             </a:ext>
           </a:extLst>
         </p:spPr>
@@ -18993,7 +19114,7 @@
           </a:prstGeom>
           <a:extLst>
             <a:ext uri="{C572A759-6A51-4108-AA02-DFA0A04FC94B}">
-              <ma14:wrappingTextBoxFlag xmlns:ma14="http://schemas.microsoft.com/office/mac/drawingml/2011/main" xmlns="" val="0"/>
+              <ma14:wrappingTextBoxFlag xmlns="" xmlns:ma14="http://schemas.microsoft.com/office/mac/drawingml/2011/main" val="0"/>
             </a:ext>
           </a:extLst>
         </p:spPr>

</xml_diff>